<commit_message>
feat: modification de la fonction récompense
</commit_message>
<xml_diff>
--- a/Autonomous Driving in Roundabout Maneuvers Using Reinforcement Learning.pptx
+++ b/Autonomous Driving in Roundabout Maneuvers Using Reinforcement Learning.pptx
@@ -5,12 +5,13 @@
     <p:sldMasterId id="2147483648" r:id="rId1"/>
   </p:sldMasterIdLst>
   <p:sldIdLst>
-    <p:sldId id="256" r:id="rId2"/>
-    <p:sldId id="257" r:id="rId3"/>
-    <p:sldId id="258" r:id="rId4"/>
-    <p:sldId id="259" r:id="rId5"/>
-    <p:sldId id="260" r:id="rId6"/>
-    <p:sldId id="261" r:id="rId7"/>
+    <p:sldId id="262" r:id="rId2"/>
+    <p:sldId id="256" r:id="rId3"/>
+    <p:sldId id="257" r:id="rId4"/>
+    <p:sldId id="258" r:id="rId5"/>
+    <p:sldId id="259" r:id="rId6"/>
+    <p:sldId id="260" r:id="rId7"/>
+    <p:sldId id="261" r:id="rId8"/>
   </p:sldIdLst>
   <p:sldSz cx="12192000" cy="6858000"/>
   <p:notesSz cx="6858000" cy="9144000"/>
@@ -109,6 +110,11 @@
       </a:defRPr>
     </a:lvl9pPr>
   </p:defaultTextStyle>
+  <p:extLst>
+    <p:ext uri="{EFAFB233-063F-42B5-8137-9DF3F51BA10A}">
+      <p15:sldGuideLst xmlns:p15="http://schemas.microsoft.com/office/powerpoint/2012/main"/>
+    </p:ext>
+  </p:extLst>
 </p:presentation>
 </file>
 
@@ -3312,6 +3318,256 @@
 <file path=ppt/slides/slide1.xml><?xml version="1.0" encoding="utf-8"?>
 <p:sld xmlns:a="http://schemas.openxmlformats.org/drawingml/2006/main" xmlns:r="http://schemas.openxmlformats.org/officeDocument/2006/relationships" xmlns:p="http://schemas.openxmlformats.org/presentationml/2006/main">
   <p:cSld>
+    <p:spTree>
+      <p:nvGrpSpPr>
+        <p:cNvPr id="1" name=""/>
+        <p:cNvGrpSpPr/>
+        <p:nvPr/>
+      </p:nvGrpSpPr>
+      <p:grpSpPr>
+        <a:xfrm>
+          <a:off x="0" y="0"/>
+          <a:ext cx="0" cy="0"/>
+          <a:chOff x="0" y="0"/>
+          <a:chExt cx="0" cy="0"/>
+        </a:xfrm>
+      </p:grpSpPr>
+      <p:sp>
+        <p:nvSpPr>
+          <p:cNvPr id="2" name="Titre 1">
+            <a:extLst>
+              <a:ext uri="{FF2B5EF4-FFF2-40B4-BE49-F238E27FC236}">
+                <a16:creationId xmlns:a16="http://schemas.microsoft.com/office/drawing/2014/main" id="{40065C94-5EC7-A475-A3D6-85A9FF072F5F}"/>
+              </a:ext>
+            </a:extLst>
+          </p:cNvPr>
+          <p:cNvSpPr>
+            <a:spLocks noGrp="1"/>
+          </p:cNvSpPr>
+          <p:nvPr>
+            <p:ph type="title"/>
+          </p:nvPr>
+        </p:nvSpPr>
+        <p:spPr/>
+        <p:txBody>
+          <a:bodyPr/>
+          <a:lstStyle/>
+          <a:p>
+            <a:r>
+              <a:rPr lang="fr-FR" dirty="0"/>
+              <a:t>Présentation du Blackjack de Gymnasium</a:t>
+            </a:r>
+          </a:p>
+        </p:txBody>
+      </p:sp>
+      <p:sp>
+        <p:nvSpPr>
+          <p:cNvPr id="3" name="Espace réservé du contenu 2">
+            <a:extLst>
+              <a:ext uri="{FF2B5EF4-FFF2-40B4-BE49-F238E27FC236}">
+                <a16:creationId xmlns:a16="http://schemas.microsoft.com/office/drawing/2014/main" id="{FCB540FD-BC21-D343-D8C2-00546A75B4E7}"/>
+              </a:ext>
+            </a:extLst>
+          </p:cNvPr>
+          <p:cNvSpPr>
+            <a:spLocks noGrp="1"/>
+          </p:cNvSpPr>
+          <p:nvPr>
+            <p:ph idx="1"/>
+          </p:nvPr>
+        </p:nvSpPr>
+        <p:spPr/>
+        <p:txBody>
+          <a:bodyPr>
+            <a:normAutofit lnSpcReduction="10000"/>
+          </a:bodyPr>
+          <a:lstStyle/>
+          <a:p>
+            <a:r>
+              <a:rPr lang="fr-FR" sz="1800" dirty="0"/>
+              <a:t>Environnement</a:t>
+            </a:r>
+          </a:p>
+          <a:p>
+            <a:r>
+              <a:rPr lang="fr-FR" sz="1800" dirty="0"/>
+              <a:t>Action : </a:t>
+            </a:r>
+            <a:r>
+              <a:rPr lang="fr-FR" sz="1800" dirty="0" err="1"/>
+              <a:t>Discrete</a:t>
+            </a:r>
+            <a:r>
+              <a:rPr lang="fr-FR" sz="1800" dirty="0"/>
+              <a:t>(2) -&gt; 0 : Stick / 1 : Hit</a:t>
+            </a:r>
+          </a:p>
+          <a:p>
+            <a:r>
+              <a:rPr lang="fr-FR" sz="1800" dirty="0"/>
+              <a:t>Observation : Tuple(</a:t>
+            </a:r>
+            <a:r>
+              <a:rPr lang="fr-FR" sz="1800" dirty="0" err="1"/>
+              <a:t>Discrete</a:t>
+            </a:r>
+            <a:r>
+              <a:rPr lang="fr-FR" sz="1800" dirty="0"/>
+              <a:t>(32), </a:t>
+            </a:r>
+            <a:r>
+              <a:rPr lang="fr-FR" sz="1800" dirty="0" err="1"/>
+              <a:t>Discrete</a:t>
+            </a:r>
+            <a:r>
+              <a:rPr lang="fr-FR" sz="1800" dirty="0"/>
+              <a:t>(11), </a:t>
+            </a:r>
+            <a:r>
+              <a:rPr lang="fr-FR" sz="1800" dirty="0" err="1"/>
+              <a:t>Discrete</a:t>
+            </a:r>
+            <a:r>
+              <a:rPr lang="fr-FR" sz="1800" dirty="0"/>
+              <a:t>(2))</a:t>
+            </a:r>
+          </a:p>
+          <a:p>
+            <a:r>
+              <a:rPr lang="fr-FR" sz="1800" dirty="0"/>
+              <a:t>Episode End : </a:t>
+            </a:r>
+          </a:p>
+          <a:p>
+            <a:pPr lvl="1"/>
+            <a:r>
+              <a:rPr lang="fr-FR" sz="1400" dirty="0"/>
+              <a:t>The </a:t>
+            </a:r>
+            <a:r>
+              <a:rPr lang="fr-FR" sz="1400" dirty="0" err="1"/>
+              <a:t>player</a:t>
+            </a:r>
+            <a:r>
+              <a:rPr lang="fr-FR" sz="1400" dirty="0"/>
+              <a:t> hits and the </a:t>
+            </a:r>
+            <a:r>
+              <a:rPr lang="fr-FR" sz="1400" dirty="0" err="1"/>
+              <a:t>sum</a:t>
+            </a:r>
+            <a:r>
+              <a:rPr lang="fr-FR" sz="1400" dirty="0"/>
+              <a:t> of hand </a:t>
+            </a:r>
+            <a:r>
+              <a:rPr lang="fr-FR" sz="1400" dirty="0" err="1"/>
+              <a:t>exceeds</a:t>
+            </a:r>
+            <a:r>
+              <a:rPr lang="fr-FR" sz="1400" dirty="0"/>
+              <a:t> 21</a:t>
+            </a:r>
+          </a:p>
+          <a:p>
+            <a:pPr lvl="1"/>
+            <a:r>
+              <a:rPr lang="fr-FR" sz="1400" dirty="0"/>
+              <a:t>The </a:t>
+            </a:r>
+            <a:r>
+              <a:rPr lang="fr-FR" sz="1400" dirty="0" err="1"/>
+              <a:t>player</a:t>
+            </a:r>
+            <a:r>
+              <a:rPr lang="fr-FR" sz="1400" dirty="0"/>
+              <a:t> sticks</a:t>
+            </a:r>
+          </a:p>
+          <a:p>
+            <a:r>
+              <a:rPr lang="fr-FR" sz="1800" dirty="0"/>
+              <a:t>Récompense : </a:t>
+            </a:r>
+          </a:p>
+          <a:p>
+            <a:pPr lvl="1"/>
+            <a:r>
+              <a:rPr lang="fr-FR" sz="1400" dirty="0"/>
+              <a:t>Win = +1  </a:t>
+            </a:r>
+          </a:p>
+          <a:p>
+            <a:pPr lvl="1"/>
+            <a:r>
+              <a:rPr lang="fr-FR" sz="1400" dirty="0"/>
+              <a:t>Lose = -1 </a:t>
+            </a:r>
+          </a:p>
+          <a:p>
+            <a:pPr lvl="1"/>
+            <a:r>
+              <a:rPr lang="fr-FR" sz="1400" dirty="0" err="1"/>
+              <a:t>Draw</a:t>
+            </a:r>
+            <a:r>
+              <a:rPr lang="fr-FR" sz="1400" dirty="0"/>
+              <a:t> = 0 </a:t>
+            </a:r>
+          </a:p>
+          <a:p>
+            <a:pPr lvl="1"/>
+            <a:r>
+              <a:rPr lang="fr-FR" sz="1400" dirty="0"/>
+              <a:t>Win Blackjack naturel  = +1,5 </a:t>
+            </a:r>
+          </a:p>
+          <a:p>
+            <a:r>
+              <a:rPr lang="fr-FR" sz="1800" dirty="0"/>
+              <a:t>Card values :</a:t>
+            </a:r>
+          </a:p>
+          <a:p>
+            <a:pPr lvl="1"/>
+            <a:r>
+              <a:rPr lang="en-US" sz="1600" dirty="0"/>
+              <a:t>Face cards (Jack, Queen, King) have a point value of 10.</a:t>
+            </a:r>
+          </a:p>
+          <a:p>
+            <a:pPr lvl="1"/>
+            <a:r>
+              <a:rPr lang="en-US" sz="1600" dirty="0"/>
+              <a:t>Aces can either count as 11 (called a ‘usable ace’) or 1.</a:t>
+            </a:r>
+          </a:p>
+          <a:p>
+            <a:pPr lvl="1"/>
+            <a:r>
+              <a:rPr lang="en-US" sz="1600" dirty="0"/>
+              <a:t>Numerical cards (2-10) have a value equal to their number.</a:t>
+            </a:r>
+            <a:endParaRPr lang="fr-FR" sz="1600" dirty="0"/>
+          </a:p>
+        </p:txBody>
+      </p:sp>
+    </p:spTree>
+    <p:extLst>
+      <p:ext uri="{BB962C8B-B14F-4D97-AF65-F5344CB8AC3E}">
+        <p14:creationId xmlns:p14="http://schemas.microsoft.com/office/powerpoint/2010/main" val="2974987083"/>
+      </p:ext>
+    </p:extLst>
+  </p:cSld>
+  <p:clrMapOvr>
+    <a:masterClrMapping/>
+  </p:clrMapOvr>
+</p:sld>
+</file>
+
+<file path=ppt/slides/slide2.xml><?xml version="1.0" encoding="utf-8"?>
+<p:sld xmlns:a="http://schemas.openxmlformats.org/drawingml/2006/main" xmlns:r="http://schemas.openxmlformats.org/officeDocument/2006/relationships" xmlns:p="http://schemas.openxmlformats.org/presentationml/2006/main">
+  <p:cSld>
     <p:bg>
       <p:bgPr>
         <a:solidFill>
@@ -3725,7 +3981,7 @@
 </p:sld>
 </file>
 
-<file path=ppt/slides/slide2.xml><?xml version="1.0" encoding="utf-8"?>
+<file path=ppt/slides/slide3.xml><?xml version="1.0" encoding="utf-8"?>
 <p:sld xmlns:a="http://schemas.openxmlformats.org/drawingml/2006/main" xmlns:r="http://schemas.openxmlformats.org/officeDocument/2006/relationships" xmlns:p="http://schemas.openxmlformats.org/presentationml/2006/main">
   <p:cSld>
     <p:bg>
@@ -3990,7 +4246,7 @@
 </p:sld>
 </file>
 
-<file path=ppt/slides/slide3.xml><?xml version="1.0" encoding="utf-8"?>
+<file path=ppt/slides/slide4.xml><?xml version="1.0" encoding="utf-8"?>
 <p:sld xmlns:a="http://schemas.openxmlformats.org/drawingml/2006/main" xmlns:r="http://schemas.openxmlformats.org/officeDocument/2006/relationships" xmlns:p="http://schemas.openxmlformats.org/presentationml/2006/main">
   <p:cSld>
     <p:bg>
@@ -6530,7 +6786,7 @@
 </p:sld>
 </file>
 
-<file path=ppt/slides/slide4.xml><?xml version="1.0" encoding="utf-8"?>
+<file path=ppt/slides/slide5.xml><?xml version="1.0" encoding="utf-8"?>
 <p:sld xmlns:a="http://schemas.openxmlformats.org/drawingml/2006/main" xmlns:r="http://schemas.openxmlformats.org/officeDocument/2006/relationships" xmlns:p="http://schemas.openxmlformats.org/presentationml/2006/main">
   <p:cSld>
     <p:bg>
@@ -9264,7 +9520,7 @@
 </p:sld>
 </file>
 
-<file path=ppt/slides/slide5.xml><?xml version="1.0" encoding="utf-8"?>
+<file path=ppt/slides/slide6.xml><?xml version="1.0" encoding="utf-8"?>
 <p:sld xmlns:a="http://schemas.openxmlformats.org/drawingml/2006/main" xmlns:r="http://schemas.openxmlformats.org/officeDocument/2006/relationships" xmlns:p="http://schemas.openxmlformats.org/presentationml/2006/main">
   <p:cSld>
     <p:bg>
@@ -11998,7 +12254,7 @@
 </p:sld>
 </file>
 
-<file path=ppt/slides/slide6.xml><?xml version="1.0" encoding="utf-8"?>
+<file path=ppt/slides/slide7.xml><?xml version="1.0" encoding="utf-8"?>
 <p:sld xmlns:a="http://schemas.openxmlformats.org/drawingml/2006/main" xmlns:r="http://schemas.openxmlformats.org/officeDocument/2006/relationships" xmlns:p="http://schemas.openxmlformats.org/presentationml/2006/main">
   <p:cSld>
     <p:spTree>

</xml_diff>